<commit_message>
minor improvements to 2 slides
</commit_message>
<xml_diff>
--- a/PowerPoints/10 - CVM.pptx
+++ b/PowerPoints/10 - CVM.pptx
@@ -18,7 +18,7 @@
     <p:sldId id="275" r:id="rId6"/>
     <p:sldId id="263" r:id="rId7"/>
     <p:sldId id="374" r:id="rId8"/>
-    <p:sldId id="375" r:id="rId9"/>
+    <p:sldId id="376" r:id="rId9"/>
     <p:sldId id="259" r:id="rId10"/>
     <p:sldId id="272" r:id="rId11"/>
     <p:sldId id="277" r:id="rId12"/>
@@ -20516,6 +20516,61 @@
           </a:p>
         </p:txBody>
       </p:sp>
+      <p:sp>
+        <p:nvSpPr>
+          <p:cNvPr id="2" name="TextBox 1">
+            <a:extLst>
+              <a:ext uri="{FF2B5EF4-FFF2-40B4-BE49-F238E27FC236}">
+                <a16:creationId xmlns:a16="http://schemas.microsoft.com/office/drawing/2014/main" id="{D55E01D1-10A5-4771-D77A-83D56580CD0F}"/>
+              </a:ext>
+            </a:extLst>
+          </p:cNvPr>
+          <p:cNvSpPr txBox="1"/>
+          <p:nvPr/>
+        </p:nvSpPr>
+        <p:spPr>
+          <a:xfrm>
+            <a:off x="802379" y="4876800"/>
+            <a:ext cx="7539243" cy="1015663"/>
+          </a:xfrm>
+          <a:prstGeom prst="rect">
+            <a:avLst/>
+          </a:prstGeom>
+          <a:noFill/>
+          <a:ln>
+            <a:solidFill>
+              <a:schemeClr val="tx1"/>
+            </a:solidFill>
+          </a:ln>
+        </p:spPr>
+        <p:txBody>
+          <a:bodyPr wrap="none" rtlCol="0">
+            <a:spAutoFit/>
+          </a:bodyPr>
+          <a:lstStyle/>
+          <a:p>
+            <a:pPr algn="l"/>
+            <a:r>
+              <a:rPr lang="en-US" sz="2000" dirty="0"/>
+              <a:t>Similar to the JVM, the CVM uses big-endian order for multibyte</a:t>
+            </a:r>
+          </a:p>
+          <a:p>
+            <a:pPr algn="l"/>
+            <a:r>
+              <a:rPr lang="en-US" sz="2000" dirty="0"/>
+              <a:t>data items; i.e., the most significant byte of a multi-byte data item</a:t>
+            </a:r>
+          </a:p>
+          <a:p>
+            <a:pPr algn="l"/>
+            <a:r>
+              <a:rPr lang="en-US" sz="2000" dirty="0"/>
+              <a:t>(character, integer, etc.) is stored at the lowest memory address.</a:t>
+            </a:r>
+          </a:p>
+        </p:txBody>
+      </p:sp>
     </p:spTree>
   </p:cSld>
   <p:clrMapOvr>
@@ -23115,11 +23170,47 @@
               <a:rPr lang="en-US" sz="2000" dirty="0">
                 <a:latin typeface="Consolas" panose="020B0609020204030204" pitchFamily="49" charset="0"/>
               </a:rPr>
+              <a:t>DIV</a:t>
+            </a:r>
+            <a:r>
+              <a:rPr lang="en-US" sz="2000" dirty="0"/>
+              <a:t>, </a:t>
+            </a:r>
+            <a:r>
+              <a:rPr lang="en-US" sz="2000" dirty="0">
+                <a:latin typeface="Consolas" panose="020B0609020204030204" pitchFamily="49" charset="0"/>
+              </a:rPr>
               <a:t>INC</a:t>
             </a:r>
             <a:r>
               <a:rPr lang="en-US" sz="2000" dirty="0"/>
-              <a:t>, etc.</a:t>
+              <a:t>, </a:t>
+            </a:r>
+            <a:r>
+              <a:rPr lang="en-US" sz="2000" dirty="0">
+                <a:latin typeface="Consolas" panose="020B0609020204030204" pitchFamily="49" charset="0"/>
+              </a:rPr>
+              <a:t>DEC</a:t>
+            </a:r>
+            <a:r>
+              <a:rPr lang="en-US" sz="2000" dirty="0"/>
+              <a:t>, </a:t>
+            </a:r>
+            <a:r>
+              <a:rPr lang="en-US" sz="2000" dirty="0">
+                <a:latin typeface="Consolas" panose="020B0609020204030204" pitchFamily="49" charset="0"/>
+              </a:rPr>
+              <a:t>MOD</a:t>
+            </a:r>
+            <a:r>
+              <a:rPr lang="en-US" sz="2000" dirty="0"/>
+              <a:t>, </a:t>
+            </a:r>
+            <a:r>
+              <a:rPr lang="en-US" sz="2000" dirty="0">
+                <a:latin typeface="Consolas" panose="020B0609020204030204" pitchFamily="49" charset="0"/>
+              </a:rPr>
+              <a:t>NEG</a:t>
             </a:r>
           </a:p>
           <a:p>
@@ -23255,7 +23346,7 @@
               <a:rPr lang="en-US" sz="2000" dirty="0">
                 <a:latin typeface="Consolas" panose="020B0609020204030204" pitchFamily="49" charset="0"/>
               </a:rPr>
-              <a:t>BG</a:t>
+              <a:t>BNE</a:t>
             </a:r>
             <a:r>
               <a:rPr lang="en-US" sz="2000" dirty="0"/>
@@ -23265,7 +23356,7 @@
               <a:rPr lang="en-US" sz="2000" dirty="0">
                 <a:latin typeface="Consolas" panose="020B0609020204030204" pitchFamily="49" charset="0"/>
               </a:rPr>
-              <a:t>BGE</a:t>
+              <a:t>BG</a:t>
             </a:r>
             <a:r>
               <a:rPr lang="en-US" sz="2000" dirty="0"/>
@@ -23275,7 +23366,89 @@
               <a:rPr lang="en-US" sz="2000" dirty="0">
                 <a:latin typeface="Consolas" panose="020B0609020204030204" pitchFamily="49" charset="0"/>
               </a:rPr>
+              <a:t>BGE</a:t>
+            </a:r>
+            <a:r>
+              <a:rPr lang="en-US" sz="2000" dirty="0"/>
+              <a:t>, </a:t>
+            </a:r>
+            <a:r>
+              <a:rPr lang="en-US" sz="2000" dirty="0">
+                <a:latin typeface="Consolas" panose="020B0609020204030204" pitchFamily="49" charset="0"/>
+              </a:rPr>
+              <a:t>BL</a:t>
+            </a:r>
+            <a:r>
+              <a:rPr lang="en-US" sz="2000" dirty="0"/>
+              <a:t>, </a:t>
+            </a:r>
+            <a:r>
+              <a:rPr lang="en-US" sz="2000" dirty="0">
+                <a:latin typeface="Consolas" panose="020B0609020204030204" pitchFamily="49" charset="0"/>
+              </a:rPr>
+              <a:t>BLE</a:t>
+            </a:r>
+            <a:r>
+              <a:rPr lang="en-US" sz="2000" dirty="0"/>
+              <a:t>, </a:t>
+            </a:r>
+            <a:r>
+              <a:rPr lang="en-US" sz="2000" dirty="0">
+                <a:latin typeface="Consolas" panose="020B0609020204030204" pitchFamily="49" charset="0"/>
+              </a:rPr>
               <a:t>BZ</a:t>
+            </a:r>
+            <a:r>
+              <a:rPr lang="en-US" sz="2000" dirty="0"/>
+              <a:t>, </a:t>
+            </a:r>
+            <a:r>
+              <a:rPr lang="en-US" sz="2000" dirty="0">
+                <a:latin typeface="Consolas" panose="020B0609020204030204" pitchFamily="49" charset="0"/>
+              </a:rPr>
+              <a:t>BNZ</a:t>
+            </a:r>
+          </a:p>
+          <a:p>
+            <a:r>
+              <a:rPr lang="en-US" dirty="0"/>
+              <a:t>Load/Store Opcodes: </a:t>
+            </a:r>
+            <a:r>
+              <a:rPr lang="en-US" sz="2000" dirty="0">
+                <a:latin typeface="Consolas" panose="020B0609020204030204" pitchFamily="49" charset="0"/>
+              </a:rPr>
+              <a:t>LOADW</a:t>
+            </a:r>
+            <a:r>
+              <a:rPr lang="en-US" sz="2000" dirty="0"/>
+              <a:t>, </a:t>
+            </a:r>
+            <a:r>
+              <a:rPr lang="en-US" sz="2000" dirty="0">
+                <a:latin typeface="Consolas" panose="020B0609020204030204" pitchFamily="49" charset="0"/>
+              </a:rPr>
+              <a:t>LDCINT</a:t>
+            </a:r>
+            <a:r>
+              <a:rPr lang="en-US" sz="2000" dirty="0"/>
+              <a:t>, </a:t>
+            </a:r>
+            <a:r>
+              <a:rPr lang="en-US" sz="2000" dirty="0">
+                <a:latin typeface="Consolas" panose="020B0609020204030204" pitchFamily="49" charset="0"/>
+              </a:rPr>
+              <a:t>LDGADDR</a:t>
+            </a:r>
+            <a:r>
+              <a:rPr lang="en-US" sz="2000" dirty="0"/>
+              <a:t>, </a:t>
+            </a:r>
+            <a:r>
+              <a:rPr lang="en-US" sz="2000" dirty="0">
+                <a:latin typeface="Consolas" panose="020B0609020204030204" pitchFamily="49" charset="0"/>
+              </a:rPr>
+              <a:t>STOREW</a:t>
             </a:r>
             <a:r>
               <a:rPr lang="en-US" sz="2000" dirty="0"/>
@@ -23285,13 +23458,13 @@
           <a:p>
             <a:r>
               <a:rPr lang="en-US" dirty="0"/>
-              <a:t>Load/Store Opcodes: </a:t>
+              <a:t>Program/Procedure Opcodes: </a:t>
             </a:r>
             <a:r>
               <a:rPr lang="en-US" sz="2000" dirty="0">
                 <a:latin typeface="Consolas" panose="020B0609020204030204" pitchFamily="49" charset="0"/>
               </a:rPr>
-              <a:t>LOADW</a:t>
+              <a:t>PROGRAM</a:t>
             </a:r>
             <a:r>
               <a:rPr lang="en-US" sz="2000" dirty="0"/>
@@ -23301,7 +23474,7 @@
               <a:rPr lang="en-US" sz="2000" dirty="0">
                 <a:latin typeface="Consolas" panose="020B0609020204030204" pitchFamily="49" charset="0"/>
               </a:rPr>
-              <a:t>LDCINT</a:t>
+              <a:t>PROC</a:t>
             </a:r>
             <a:r>
               <a:rPr lang="en-US" sz="2000" dirty="0"/>
@@ -23311,7 +23484,7 @@
               <a:rPr lang="en-US" sz="2000" dirty="0">
                 <a:latin typeface="Consolas" panose="020B0609020204030204" pitchFamily="49" charset="0"/>
               </a:rPr>
-              <a:t>LDGADDR</a:t>
+              <a:t>CALL</a:t>
             </a:r>
             <a:r>
               <a:rPr lang="en-US" sz="2000" dirty="0"/>
@@ -23321,23 +23494,24 @@
               <a:rPr lang="en-US" sz="2000" dirty="0">
                 <a:latin typeface="Consolas" panose="020B0609020204030204" pitchFamily="49" charset="0"/>
               </a:rPr>
-              <a:t>STOREW</a:t>
+              <a:t>RET</a:t>
             </a:r>
             <a:r>
               <a:rPr lang="en-US" sz="2000" dirty="0"/>
               <a:t>, etc.</a:t>
             </a:r>
-          </a:p>
-          <a:p>
-            <a:r>
-              <a:rPr lang="en-US" dirty="0"/>
-              <a:t>Program/Procedure Opcodes: </a:t>
+            <a:endParaRPr lang="en-US" dirty="0"/>
+          </a:p>
+          <a:p>
+            <a:r>
+              <a:rPr lang="en-US" dirty="0"/>
+              <a:t>I/O Opcodes: </a:t>
             </a:r>
             <a:r>
               <a:rPr lang="en-US" sz="2000" dirty="0">
                 <a:latin typeface="Consolas" panose="020B0609020204030204" pitchFamily="49" charset="0"/>
               </a:rPr>
-              <a:t>PROGRAM</a:t>
+              <a:t>GETINT</a:t>
             </a:r>
             <a:r>
               <a:rPr lang="en-US" sz="2000" dirty="0"/>
@@ -23347,7 +23521,7 @@
               <a:rPr lang="en-US" sz="2000" dirty="0">
                 <a:latin typeface="Consolas" panose="020B0609020204030204" pitchFamily="49" charset="0"/>
               </a:rPr>
-              <a:t>PROC</a:t>
+              <a:t>GETCH</a:t>
             </a:r>
             <a:r>
               <a:rPr lang="en-US" sz="2000" dirty="0"/>
@@ -23357,44 +23531,7 @@
               <a:rPr lang="en-US" sz="2000" dirty="0">
                 <a:latin typeface="Consolas" panose="020B0609020204030204" pitchFamily="49" charset="0"/>
               </a:rPr>
-              <a:t>CALL</a:t>
-            </a:r>
-            <a:r>
-              <a:rPr lang="en-US" sz="2000" dirty="0"/>
-              <a:t>, </a:t>
-            </a:r>
-            <a:r>
-              <a:rPr lang="en-US" sz="2000" dirty="0">
-                <a:latin typeface="Consolas" panose="020B0609020204030204" pitchFamily="49" charset="0"/>
-              </a:rPr>
-              <a:t>RET</a:t>
-            </a:r>
-            <a:r>
-              <a:rPr lang="en-US" sz="2000" dirty="0"/>
-              <a:t>, etc.</a:t>
-            </a:r>
-            <a:endParaRPr lang="en-US" dirty="0"/>
-          </a:p>
-          <a:p>
-            <a:r>
-              <a:rPr lang="en-US" dirty="0"/>
-              <a:t>I/O Opcodes: </a:t>
-            </a:r>
-            <a:r>
-              <a:rPr lang="en-US" sz="2000" dirty="0">
-                <a:latin typeface="Consolas" panose="020B0609020204030204" pitchFamily="49" charset="0"/>
-              </a:rPr>
-              <a:t>GETINT</a:t>
-            </a:r>
-            <a:r>
-              <a:rPr lang="en-US" sz="2000" dirty="0"/>
-              <a:t>, </a:t>
-            </a:r>
-            <a:r>
-              <a:rPr lang="en-US" sz="2000" dirty="0">
-                <a:latin typeface="Consolas" panose="020B0609020204030204" pitchFamily="49" charset="0"/>
-              </a:rPr>
-              <a:t>GETCH</a:t>
+              <a:t>GETSTR</a:t>
             </a:r>
             <a:r>
               <a:rPr lang="en-US" sz="2000" dirty="0"/>
@@ -23497,7 +23634,7 @@
     </p:spTree>
     <p:extLst>
       <p:ext uri="{BB962C8B-B14F-4D97-AF65-F5344CB8AC3E}">
-        <p14:creationId xmlns:p14="http://schemas.microsoft.com/office/powerpoint/2010/main" val="741811173"/>
+        <p14:creationId xmlns:p14="http://schemas.microsoft.com/office/powerpoint/2010/main" val="2498743217"/>
       </p:ext>
     </p:extLst>
   </p:cSld>

</xml_diff>

<commit_message>
minor updates to two slides
</commit_message>
<xml_diff>
--- a/PowerPoints/10 - CVM.pptx
+++ b/PowerPoints/10 - CVM.pptx
@@ -21,7 +21,7 @@
     <p:sldId id="376" r:id="rId9"/>
     <p:sldId id="259" r:id="rId10"/>
     <p:sldId id="272" r:id="rId11"/>
-    <p:sldId id="277" r:id="rId12"/>
+    <p:sldId id="377" r:id="rId12"/>
     <p:sldId id="271" r:id="rId13"/>
     <p:sldId id="260" r:id="rId14"/>
     <p:sldId id="274" r:id="rId15"/>
@@ -4589,8 +4589,8 @@
         </p:nvSpPr>
         <p:spPr>
           <a:xfrm>
-            <a:off x="458788" y="1363663"/>
-            <a:ext cx="8226425" cy="4935537"/>
+            <a:off x="381000" y="1363663"/>
+            <a:ext cx="8412480" cy="4935537"/>
           </a:xfrm>
         </p:spPr>
         <p:txBody>
@@ -4598,8 +4598,8 @@
           <a:lstStyle/>
           <a:p>
             <a:r>
-              <a:rPr lang="en-US" dirty="0"/>
-              <a:t>Suppose a program contains the following declarations.</a:t>
+              <a:rPr lang="en-US" sz="2250" dirty="0"/>
+              <a:t>Suppose a program contains the following global declarations.</a:t>
             </a:r>
           </a:p>
           <a:p>
@@ -4611,17 +4611,6 @@
                 <a:latin typeface="Consolas" panose="020B0609020204030204" pitchFamily="49" charset="0"/>
               </a:rPr>
               <a:t>var m, n : Integer;</a:t>
-            </a:r>
-          </a:p>
-          <a:p>
-            <a:pPr marL="457200" lvl="1" indent="0">
-              <a:buNone/>
-            </a:pPr>
-            <a:r>
-              <a:rPr lang="en-US" sz="1800" dirty="0">
-                <a:latin typeface="Consolas" panose="020B0609020204030204" pitchFamily="49" charset="0"/>
-              </a:rPr>
-              <a:t>var c : Char;</a:t>
             </a:r>
           </a:p>
           <a:p>
@@ -4635,12 +4624,26 @@
               <a:rPr lang="en-US" sz="1800" dirty="0">
                 <a:latin typeface="Consolas" panose="020B0609020204030204" pitchFamily="49" charset="0"/>
               </a:rPr>
+              <a:t>var c : Char;</a:t>
+            </a:r>
+          </a:p>
+          <a:p>
+            <a:pPr marL="457200" lvl="1" indent="0">
+              <a:spcBef>
+                <a:spcPts val="200"/>
+              </a:spcBef>
+              <a:buNone/>
+            </a:pPr>
+            <a:r>
+              <a:rPr lang="en-US" sz="1800" dirty="0">
+                <a:latin typeface="Consolas" panose="020B0609020204030204" pitchFamily="49" charset="0"/>
+              </a:rPr>
               <a:t>var a, b : Boolean;</a:t>
             </a:r>
           </a:p>
           <a:p>
             <a:r>
-              <a:rPr lang="en-US" dirty="0"/>
+              <a:rPr lang="en-US" sz="2250" dirty="0"/>
               <a:t>The relative addresses of the variables are as follows.</a:t>
             </a:r>
           </a:p>
@@ -4705,14 +4708,14 @@
           </a:p>
           <a:p>
             <a:r>
-              <a:rPr lang="en-US" dirty="0"/>
+              <a:rPr lang="en-US" sz="2250" dirty="0"/>
               <a:t>The total variable length</a:t>
             </a:r>
             <a:br>
-              <a:rPr lang="en-US" dirty="0"/>
+              <a:rPr lang="en-US" sz="2250" dirty="0"/>
             </a:br>
             <a:r>
-              <a:rPr lang="en-US" dirty="0"/>
+              <a:rPr lang="en-US" sz="2250" dirty="0"/>
               <a:t>for the program is 12.</a:t>
             </a:r>
           </a:p>
@@ -4785,13 +4788,15 @@
               </a:ext>
             </a:extLst>
           </p:cNvPr>
-          <p:cNvGrpSpPr/>
+          <p:cNvGrpSpPr>
+            <a:grpSpLocks noChangeAspect="1"/>
+          </p:cNvGrpSpPr>
           <p:nvPr/>
         </p:nvGrpSpPr>
         <p:grpSpPr>
           <a:xfrm>
-            <a:off x="4510670" y="3333750"/>
-            <a:ext cx="4174543" cy="2914650"/>
+            <a:off x="4419600" y="3200400"/>
+            <a:ext cx="4059948" cy="2834640"/>
             <a:chOff x="4283657" y="3048000"/>
             <a:chExt cx="4174543" cy="2914650"/>
           </a:xfrm>
@@ -5996,7 +6001,7 @@
     </p:spTree>
     <p:extLst>
       <p:ext uri="{BB962C8B-B14F-4D97-AF65-F5344CB8AC3E}">
-        <p14:creationId xmlns:p14="http://schemas.microsoft.com/office/powerpoint/2010/main" val="2196249399"/>
+        <p14:creationId xmlns:p14="http://schemas.microsoft.com/office/powerpoint/2010/main" val="1821019207"/>
       </p:ext>
     </p:extLst>
   </p:cSld>
@@ -8702,7 +8707,7 @@
                 <a:latin typeface="Consolas" pitchFamily="49" charset="0"/>
                 <a:cs typeface="Consolas" pitchFamily="49" charset="0"/>
               </a:rPr>
-              <a:t>  49:  LDCSTR  "n = "</a:t>
+              <a:t>  49:  LDCSTR "n = "</a:t>
             </a:r>
           </a:p>
           <a:p>
@@ -8798,7 +8803,7 @@
                 <a:latin typeface="Consolas" pitchFamily="49" charset="0"/>
                 <a:cs typeface="Consolas" pitchFamily="49" charset="0"/>
               </a:rPr>
-              <a:t>  71:  LDCSTR  "c = "</a:t>
+              <a:t>  71:  LDCSTR "c = "</a:t>
             </a:r>
           </a:p>
           <a:p>
@@ -23776,7 +23781,7 @@
               <a:rPr lang="en-US" dirty="0">
                 <a:cs typeface="Arial" pitchFamily="34" charset="0"/>
               </a:rPr>
-              <a:t> (program counter; a.k.a. instruction pointer) - holds address of the next instruction to be executed</a:t>
+              <a:t> (program counter; a.k.a. instruction pointer) – holds address of the next instruction to be executed</a:t>
             </a:r>
           </a:p>
           <a:p>
@@ -23792,7 +23797,7 @@
               <a:rPr lang="en-US" dirty="0">
                 <a:cs typeface="Arial" pitchFamily="34" charset="0"/>
               </a:rPr>
-              <a:t> (stack pointer) - holds address of top of the stack</a:t>
+              <a:t> (stack pointer) – holds address of top of the stack</a:t>
             </a:r>
           </a:p>
           <a:p>
@@ -23842,7 +23847,7 @@
               <a:rPr lang="en-US" dirty="0">
                 <a:cs typeface="Arial" pitchFamily="34" charset="0"/>
               </a:rPr>
-              <a:t> (base pointer) - holds base address of the subprogram currently being executed</a:t>
+              <a:t> (base pointer) – holds base address of the subprogram currently being executed</a:t>
             </a:r>
             <a:endParaRPr lang="en-US" dirty="0"/>
           </a:p>

</xml_diff>

<commit_message>
Font change on two slildes.
</commit_message>
<xml_diff>
--- a/PowerPoints/10 - CVM.pptx
+++ b/PowerPoints/10 - CVM.pptx
@@ -9006,7 +9006,27 @@
           <a:p>
             <a:r>
               <a:rPr lang="en-US" sz="2000" dirty="0"/>
-              <a:t>Note that RET 0 (5 bytes) has been optimized to RET0 (1 byte).</a:t>
+              <a:t>Note that </a:t>
+            </a:r>
+            <a:r>
+              <a:rPr lang="en-US" sz="2000" dirty="0">
+                <a:latin typeface="Consolas" panose="020B0609020204030204" pitchFamily="49" charset="0"/>
+              </a:rPr>
+              <a:t>RET 0</a:t>
+            </a:r>
+            <a:r>
+              <a:rPr lang="en-US" sz="2000" dirty="0"/>
+              <a:t> (5 bytes) has been optimized to </a:t>
+            </a:r>
+            <a:r>
+              <a:rPr lang="en-US" sz="2000" dirty="0">
+                <a:latin typeface="Consolas" panose="020B0609020204030204" pitchFamily="49" charset="0"/>
+              </a:rPr>
+              <a:t>RET0</a:t>
+            </a:r>
+            <a:r>
+              <a:rPr lang="en-US" sz="2000" dirty="0"/>
+              <a:t> (1 byte).</a:t>
             </a:r>
           </a:p>
         </p:txBody>
@@ -22969,7 +22989,20 @@
               <a:rPr lang="en-US" dirty="0">
                 <a:cs typeface="Arial" pitchFamily="34" charset="0"/>
               </a:rPr>
-              <a:t> (Load Constant Integer): Fetch the integer immediately following the opcode and push it onto the top of the stack; e.g., LDCINT 500.</a:t>
+              <a:t> (Load Constant Integer): Fetch the integer immediately following the opcode and push it onto the top of the stack; e.g., </a:t>
+            </a:r>
+            <a:r>
+              <a:rPr lang="en-US" dirty="0">
+                <a:latin typeface="Consolas" panose="020B0609020204030204" pitchFamily="49" charset="0"/>
+                <a:cs typeface="Arial" pitchFamily="34" charset="0"/>
+              </a:rPr>
+              <a:t>LDCINT 500</a:t>
+            </a:r>
+            <a:r>
+              <a:rPr lang="en-US" dirty="0">
+                <a:cs typeface="Arial" pitchFamily="34" charset="0"/>
+              </a:rPr>
+              <a:t>.</a:t>
             </a:r>
           </a:p>
           <a:p>

</xml_diff>

<commit_message>
Font change on two slides.
</commit_message>
<xml_diff>
--- a/PowerPoints/10 - CVM.pptx
+++ b/PowerPoints/10 - CVM.pptx
@@ -9006,7 +9006,27 @@
           <a:p>
             <a:r>
               <a:rPr lang="en-US" sz="2000" dirty="0"/>
-              <a:t>Note that RET 0 (5 bytes) has been optimized to RET0 (1 byte).</a:t>
+              <a:t>Note that </a:t>
+            </a:r>
+            <a:r>
+              <a:rPr lang="en-US" sz="2000" dirty="0">
+                <a:latin typeface="Consolas" panose="020B0609020204030204" pitchFamily="49" charset="0"/>
+              </a:rPr>
+              <a:t>RET 0</a:t>
+            </a:r>
+            <a:r>
+              <a:rPr lang="en-US" sz="2000" dirty="0"/>
+              <a:t> (5 bytes) has been optimized to </a:t>
+            </a:r>
+            <a:r>
+              <a:rPr lang="en-US" sz="2000" dirty="0">
+                <a:latin typeface="Consolas" panose="020B0609020204030204" pitchFamily="49" charset="0"/>
+              </a:rPr>
+              <a:t>RET0</a:t>
+            </a:r>
+            <a:r>
+              <a:rPr lang="en-US" sz="2000" dirty="0"/>
+              <a:t> (1 byte).</a:t>
             </a:r>
           </a:p>
         </p:txBody>
@@ -22969,7 +22989,20 @@
               <a:rPr lang="en-US" dirty="0">
                 <a:cs typeface="Arial" pitchFamily="34" charset="0"/>
               </a:rPr>
-              <a:t> (Load Constant Integer): Fetch the integer immediately following the opcode and push it onto the top of the stack; e.g., LDCINT 500.</a:t>
+              <a:t> (Load Constant Integer): Fetch the integer immediately following the opcode and push it onto the top of the stack; e.g., </a:t>
+            </a:r>
+            <a:r>
+              <a:rPr lang="en-US" dirty="0">
+                <a:latin typeface="Consolas" panose="020B0609020204030204" pitchFamily="49" charset="0"/>
+                <a:cs typeface="Arial" pitchFamily="34" charset="0"/>
+              </a:rPr>
+              <a:t>LDCINT 500</a:t>
+            </a:r>
+            <a:r>
+              <a:rPr lang="en-US" dirty="0">
+                <a:cs typeface="Arial" pitchFamily="34" charset="0"/>
+              </a:rPr>
+              <a:t>.</a:t>
             </a:r>
           </a:p>
           <a:p>

</xml_diff>